<commit_message>
Sjöskolan: ESA:s fyra arbetsmetoder förklarade mot SS-EN 50110-1:s tre (EL-000133, v42_02 bild 7)
Co-Authored-By: Claude Opus 5.5 <noreply@anthropic.com>
Claude-Session: https://claude.ai/code/session_011V9KjBb53XrDm23Dw58SH3
</commit_message>
<xml_diff>
--- a/sjoskolan/vecka-42/aktuell/v42_02_Regler_ansvar_och_arbetsmetoder_elev.pptx
+++ b/sjoskolan/vecka-42/aktuell/v42_02_Regler_ansvar_och_arbetsmetoder_elev.pptx
@@ -16140,7 +16140,7 @@
                 <a:ea typeface="Calibri"/>
                 <a:cs typeface="Calibri"/>
               </a:rPr>
-              <a:t>SS-EN 50110-1 har tre arbetsmetoder: utan spänning, med spänning och nära spänning (avsnitt 6.2–6.4).</a:t>
+              <a:t>SS-EN 50110-1: tre metoder (utan spänning, med spänning, nära spänning).</a:t>
             </a:r>
           </a:p>
           <a:p xmlns:a="http://schemas.openxmlformats.org/drawingml/2006/main">
@@ -16164,7 +16164,7 @@
                 <a:ea typeface="Calibri"/>
                 <a:cs typeface="Calibri"/>
               </a:rPr>
-              <a:t>ESA delar in i fyra: utan och med spänning, inom och utanför närområdet.</a:t>
+              <a:t>ESA: fyra metoder (kompletterar med arbete utanför närområde).</a:t>
             </a:r>
           </a:p>
         </p:txBody>

</xml_diff>